<commit_message>
update v3 fix top margins for safe area
</commit_message>
<xml_diff>
--- a/阿米巴經營_40頁完整講義.pptx
+++ b/阿米巴經營_40頁完整講義.pptx
@@ -4579,8 +4579,8 @@
         </p:nvSpPr>
         <p:spPr>
           <a:xfrm>
-            <a:off x="731520" y="731520"/>
-            <a:ext cx="914400" cy="1097280"/>
+            <a:off x="731520" y="914400"/>
+            <a:ext cx="914400" cy="914400"/>
           </a:xfrm>
           <a:prstGeom prst="rect">
             <a:avLst/>
@@ -4596,7 +4596,7 @@
               <a:buNone/>
             </a:pPr>
             <a:r>
-              <a:rPr lang="en-US" sz="6400" dirty="0">
+              <a:rPr lang="en-US" sz="6000" dirty="0">
                 <a:solidFill>
                   <a:srgbClr val="D4A017"/>
                 </a:solidFill>
@@ -4606,7 +4606,7 @@
               </a:rPr>
               <a:t>「</a:t>
             </a:r>
-            <a:endParaRPr lang="en-US" sz="6400" dirty="0"/>
+            <a:endParaRPr lang="en-US" sz="6000" dirty="0"/>
           </a:p>
         </p:txBody>
       </p:sp>
@@ -4618,8 +4618,8 @@
         </p:nvSpPr>
         <p:spPr>
           <a:xfrm>
-            <a:off x="1097280" y="1371600"/>
-            <a:ext cx="7132320" cy="2286000"/>
+            <a:off x="1097280" y="1645920"/>
+            <a:ext cx="6949440" cy="1828800"/>
           </a:xfrm>
           <a:prstGeom prst="rect">
             <a:avLst/>
@@ -4633,12 +4633,12 @@
           <a:p>
             <a:pPr indent="0" marL="0">
               <a:lnSpc>
-                <a:spcPts val="3200"/>
+                <a:spcPts val="3000"/>
               </a:lnSpc>
               <a:buNone/>
             </a:pPr>
             <a:r>
-              <a:rPr lang="en-US" sz="2000" dirty="0">
+              <a:rPr lang="en-US" sz="1800" dirty="0">
                 <a:solidFill>
                   <a:srgbClr val="FFFFFF"/>
                 </a:solidFill>
@@ -4648,17 +4648,17 @@
               </a:rPr>
               <a:t>讓每個小單位都像老闆一樣經營。</a:t>
             </a:r>
-            <a:endParaRPr lang="en-US" sz="2000" dirty="0"/>
+            <a:endParaRPr lang="en-US" sz="1800" dirty="0"/>
           </a:p>
           <a:p>
             <a:pPr indent="0" marL="0">
               <a:lnSpc>
-                <a:spcPts val="3200"/>
+                <a:spcPts val="3000"/>
               </a:lnSpc>
               <a:buNone/>
             </a:pPr>
             <a:r>
-              <a:rPr lang="en-US" sz="2000" dirty="0">
+              <a:rPr lang="en-US" sz="1800" dirty="0">
                 <a:solidFill>
                   <a:srgbClr val="FFFFFF"/>
                 </a:solidFill>
@@ -4668,7 +4668,7 @@
               </a:rPr>
               <a:t>全員參與、透明核算、持續改善。</a:t>
             </a:r>
-            <a:endParaRPr lang="en-US" sz="2000" dirty="0"/>
+            <a:endParaRPr lang="en-US" sz="1800" dirty="0"/>
           </a:p>
         </p:txBody>
       </p:sp>
@@ -4680,7 +4680,7 @@
         </p:nvSpPr>
         <p:spPr>
           <a:xfrm>
-            <a:off x="7315200" y="3657600"/>
+            <a:off x="7315200" y="3474720"/>
             <a:ext cx="914400" cy="731520"/>
           </a:xfrm>
           <a:prstGeom prst="rect">
@@ -4697,7 +4697,7 @@
               <a:buNone/>
             </a:pPr>
             <a:r>
-              <a:rPr lang="en-US" sz="6400" dirty="0">
+              <a:rPr lang="en-US" sz="6000" dirty="0">
                 <a:solidFill>
                   <a:srgbClr val="D4A017"/>
                 </a:solidFill>
@@ -4707,7 +4707,7 @@
               </a:rPr>
               <a:t>」</a:t>
             </a:r>
-            <a:endParaRPr lang="en-US" sz="6400" dirty="0"/>
+            <a:endParaRPr lang="en-US" sz="6000" dirty="0"/>
           </a:p>
         </p:txBody>
       </p:sp>
@@ -4719,7 +4719,7 @@
         </p:nvSpPr>
         <p:spPr>
           <a:xfrm>
-            <a:off x="1097280" y="3931920"/>
+            <a:off x="1097280" y="3840480"/>
             <a:ext cx="6400800" cy="457200"/>
           </a:xfrm>
           <a:prstGeom prst="rect">
@@ -4849,8 +4849,8 @@
         </p:nvSpPr>
         <p:spPr>
           <a:xfrm>
-            <a:off x="731520" y="1371600"/>
-            <a:ext cx="7680960" cy="548640"/>
+            <a:off x="731520" y="1645920"/>
+            <a:ext cx="7680960" cy="457200"/>
           </a:xfrm>
           <a:prstGeom prst="rect">
             <a:avLst/>
@@ -4888,7 +4888,7 @@
         </p:nvSpPr>
         <p:spPr>
           <a:xfrm>
-            <a:off x="731520" y="2011680"/>
+            <a:off x="731520" y="2194560"/>
             <a:ext cx="7680960" cy="731520"/>
           </a:xfrm>
           <a:prstGeom prst="rect">
@@ -4905,7 +4905,7 @@
               <a:buNone/>
             </a:pPr>
             <a:r>
-              <a:rPr lang="en-US" sz="3000" b="1" dirty="0">
+              <a:rPr lang="en-US" sz="2800" b="1" dirty="0">
                 <a:solidFill>
                   <a:srgbClr val="FFFFFF"/>
                 </a:solidFill>
@@ -4915,7 +4915,7 @@
               </a:rPr>
               <a:t>組織劃分與內部交易</a:t>
             </a:r>
-            <a:endParaRPr lang="en-US" sz="3000" dirty="0"/>
+            <a:endParaRPr lang="en-US" sz="2800" dirty="0"/>
           </a:p>
         </p:txBody>
       </p:sp>
@@ -4927,7 +4927,7 @@
         </p:nvSpPr>
         <p:spPr>
           <a:xfrm>
-            <a:off x="731520" y="2926080"/>
+            <a:off x="731520" y="3017520"/>
             <a:ext cx="7680960" cy="548640"/>
           </a:xfrm>
           <a:prstGeom prst="rect">
@@ -5057,7 +5057,7 @@
         </p:nvSpPr>
         <p:spPr>
           <a:xfrm>
-            <a:off x="457200" y="228600"/>
+            <a:off x="457200" y="274320"/>
             <a:ext cx="8229600" cy="457200"/>
           </a:xfrm>
           <a:prstGeom prst="rect">
@@ -5097,7 +5097,7 @@
         <p:spPr>
           <a:xfrm>
             <a:off x="457200" y="914400"/>
-            <a:ext cx="8229600" cy="3657600"/>
+            <a:ext cx="8229600" cy="3474720"/>
           </a:xfrm>
           <a:prstGeom prst="rect">
             <a:avLst/>
@@ -5226,12 +5226,12 @@
         </p:nvSpPr>
         <p:spPr>
           <a:xfrm>
-            <a:off x="457200" y="3931920"/>
-            <a:ext cx="8229600" cy="640080"/>
+            <a:off x="457200" y="3840480"/>
+            <a:ext cx="8229600" cy="731520"/>
           </a:xfrm>
           <a:prstGeom prst="roundRect">
             <a:avLst>
-              <a:gd name="adj" fmla="val 571429"/>
+              <a:gd name="adj" fmla="val 500000"/>
             </a:avLst>
           </a:prstGeom>
           <a:solidFill>
@@ -5248,8 +5248,8 @@
         </p:nvSpPr>
         <p:spPr>
           <a:xfrm>
-            <a:off x="640080" y="3977640"/>
-            <a:ext cx="7863840" cy="548640"/>
+            <a:off x="640080" y="3886200"/>
+            <a:ext cx="7863840" cy="640080"/>
           </a:xfrm>
           <a:prstGeom prst="rect">
             <a:avLst/>
@@ -5378,7 +5378,7 @@
         </p:nvSpPr>
         <p:spPr>
           <a:xfrm>
-            <a:off x="457200" y="228600"/>
+            <a:off x="457200" y="274320"/>
             <a:ext cx="8229600" cy="457200"/>
           </a:xfrm>
           <a:prstGeom prst="rect">
@@ -5418,7 +5418,7 @@
         <p:spPr>
           <a:xfrm>
             <a:off x="457200" y="914400"/>
-            <a:ext cx="8229600" cy="3657600"/>
+            <a:ext cx="8229600" cy="3474720"/>
           </a:xfrm>
           <a:prstGeom prst="rect">
             <a:avLst/>
@@ -5547,12 +5547,12 @@
         </p:nvSpPr>
         <p:spPr>
           <a:xfrm>
-            <a:off x="457200" y="3931920"/>
-            <a:ext cx="8229600" cy="640080"/>
+            <a:off x="457200" y="3840480"/>
+            <a:ext cx="8229600" cy="731520"/>
           </a:xfrm>
           <a:prstGeom prst="roundRect">
             <a:avLst>
-              <a:gd name="adj" fmla="val 571429"/>
+              <a:gd name="adj" fmla="val 500000"/>
             </a:avLst>
           </a:prstGeom>
           <a:solidFill>
@@ -5569,8 +5569,8 @@
         </p:nvSpPr>
         <p:spPr>
           <a:xfrm>
-            <a:off x="640080" y="3977640"/>
-            <a:ext cx="7863840" cy="548640"/>
+            <a:off x="640080" y="3886200"/>
+            <a:ext cx="7863840" cy="640080"/>
           </a:xfrm>
           <a:prstGeom prst="rect">
             <a:avLst/>
@@ -5699,7 +5699,7 @@
         </p:nvSpPr>
         <p:spPr>
           <a:xfrm>
-            <a:off x="457200" y="228600"/>
+            <a:off x="457200" y="274320"/>
             <a:ext cx="8229600" cy="457200"/>
           </a:xfrm>
           <a:prstGeom prst="rect">
@@ -5739,7 +5739,7 @@
         <p:spPr>
           <a:xfrm>
             <a:off x="457200" y="914400"/>
-            <a:ext cx="8229600" cy="3657600"/>
+            <a:ext cx="8229600" cy="3474720"/>
           </a:xfrm>
           <a:prstGeom prst="rect">
             <a:avLst/>
@@ -5941,8 +5941,8 @@
         </p:nvSpPr>
         <p:spPr>
           <a:xfrm>
-            <a:off x="731520" y="1371600"/>
-            <a:ext cx="7680960" cy="548640"/>
+            <a:off x="731520" y="1645920"/>
+            <a:ext cx="7680960" cy="457200"/>
           </a:xfrm>
           <a:prstGeom prst="rect">
             <a:avLst/>
@@ -5980,7 +5980,7 @@
         </p:nvSpPr>
         <p:spPr>
           <a:xfrm>
-            <a:off x="731520" y="2011680"/>
+            <a:off x="731520" y="2194560"/>
             <a:ext cx="7680960" cy="731520"/>
           </a:xfrm>
           <a:prstGeom prst="rect">
@@ -5997,7 +5997,7 @@
               <a:buNone/>
             </a:pPr>
             <a:r>
-              <a:rPr lang="en-US" sz="3000" b="1" dirty="0">
+              <a:rPr lang="en-US" sz="2800" b="1" dirty="0">
                 <a:solidFill>
                   <a:srgbClr val="FFFFFF"/>
                 </a:solidFill>
@@ -6007,7 +6007,7 @@
               </a:rPr>
               <a:t>現場計算實務</a:t>
             </a:r>
-            <a:endParaRPr lang="en-US" sz="3000" dirty="0"/>
+            <a:endParaRPr lang="en-US" sz="2800" dirty="0"/>
           </a:p>
         </p:txBody>
       </p:sp>
@@ -6019,7 +6019,7 @@
         </p:nvSpPr>
         <p:spPr>
           <a:xfrm>
-            <a:off x="731520" y="2926080"/>
+            <a:off x="731520" y="3017520"/>
             <a:ext cx="7680960" cy="548640"/>
           </a:xfrm>
           <a:prstGeom prst="rect">
@@ -6430,7 +6430,7 @@
         </p:nvSpPr>
         <p:spPr>
           <a:xfrm>
-            <a:off x="457200" y="228600"/>
+            <a:off x="457200" y="274320"/>
             <a:ext cx="8229600" cy="457200"/>
           </a:xfrm>
           <a:prstGeom prst="rect">
@@ -8462,8 +8462,8 @@
         </p:nvSpPr>
         <p:spPr>
           <a:xfrm>
-            <a:off x="731520" y="1371600"/>
-            <a:ext cx="7680960" cy="548640"/>
+            <a:off x="731520" y="1645920"/>
+            <a:ext cx="7680960" cy="457200"/>
           </a:xfrm>
           <a:prstGeom prst="rect">
             <a:avLst/>
@@ -8501,7 +8501,7 @@
         </p:nvSpPr>
         <p:spPr>
           <a:xfrm>
-            <a:off x="731520" y="2011680"/>
+            <a:off x="731520" y="2194560"/>
             <a:ext cx="7680960" cy="731520"/>
           </a:xfrm>
           <a:prstGeom prst="rect">
@@ -8518,7 +8518,7 @@
               <a:buNone/>
             </a:pPr>
             <a:r>
-              <a:rPr lang="en-US" sz="3000" b="1" dirty="0">
+              <a:rPr lang="en-US" sz="2800" b="1" dirty="0">
                 <a:solidFill>
                   <a:srgbClr val="FFFFFF"/>
                 </a:solidFill>
@@ -8528,7 +8528,7 @@
               </a:rPr>
               <a:t>改善案例</a:t>
             </a:r>
-            <a:endParaRPr lang="en-US" sz="3000" dirty="0"/>
+            <a:endParaRPr lang="en-US" sz="2800" dirty="0"/>
           </a:p>
         </p:txBody>
       </p:sp>
@@ -8540,7 +8540,7 @@
         </p:nvSpPr>
         <p:spPr>
           <a:xfrm>
-            <a:off x="731520" y="2926080"/>
+            <a:off x="731520" y="3017520"/>
             <a:ext cx="7680960" cy="548640"/>
           </a:xfrm>
           <a:prstGeom prst="rect">
@@ -8670,7 +8670,7 @@
         </p:nvSpPr>
         <p:spPr>
           <a:xfrm>
-            <a:off x="457200" y="228600"/>
+            <a:off x="457200" y="274320"/>
             <a:ext cx="8229600" cy="457200"/>
           </a:xfrm>
           <a:prstGeom prst="rect">
@@ -11741,7 +11741,7 @@
         </p:nvSpPr>
         <p:spPr>
           <a:xfrm>
-            <a:off x="457200" y="228600"/>
+            <a:off x="457200" y="274320"/>
             <a:ext cx="8229600" cy="457200"/>
           </a:xfrm>
           <a:prstGeom prst="rect">
@@ -11781,7 +11781,7 @@
         <p:spPr>
           <a:xfrm>
             <a:off x="457200" y="914400"/>
-            <a:ext cx="8229600" cy="3657600"/>
+            <a:ext cx="8229600" cy="3474720"/>
           </a:xfrm>
           <a:prstGeom prst="rect">
             <a:avLst/>
@@ -12001,8 +12001,8 @@
         </p:nvSpPr>
         <p:spPr>
           <a:xfrm>
-            <a:off x="731520" y="1371600"/>
-            <a:ext cx="7680960" cy="548640"/>
+            <a:off x="731520" y="1645920"/>
+            <a:ext cx="7680960" cy="457200"/>
           </a:xfrm>
           <a:prstGeom prst="rect">
             <a:avLst/>
@@ -12040,7 +12040,7 @@
         </p:nvSpPr>
         <p:spPr>
           <a:xfrm>
-            <a:off x="731520" y="2011680"/>
+            <a:off x="731520" y="2194560"/>
             <a:ext cx="7680960" cy="731520"/>
           </a:xfrm>
           <a:prstGeom prst="rect">
@@ -12057,7 +12057,7 @@
               <a:buNone/>
             </a:pPr>
             <a:r>
-              <a:rPr lang="en-US" sz="3000" b="1" dirty="0">
+              <a:rPr lang="en-US" sz="2800" b="1" dirty="0">
                 <a:solidFill>
                   <a:srgbClr val="FFFFFF"/>
                 </a:solidFill>
@@ -12067,7 +12067,7 @@
               </a:rPr>
               <a:t>管理體系與會議節奏</a:t>
             </a:r>
-            <a:endParaRPr lang="en-US" sz="3000" dirty="0"/>
+            <a:endParaRPr lang="en-US" sz="2800" dirty="0"/>
           </a:p>
         </p:txBody>
       </p:sp>
@@ -12079,7 +12079,7 @@
         </p:nvSpPr>
         <p:spPr>
           <a:xfrm>
-            <a:off x="731520" y="2926080"/>
+            <a:off x="731520" y="3017520"/>
             <a:ext cx="7680960" cy="548640"/>
           </a:xfrm>
           <a:prstGeom prst="rect">
@@ -12209,7 +12209,7 @@
         </p:nvSpPr>
         <p:spPr>
           <a:xfrm>
-            <a:off x="457200" y="228600"/>
+            <a:off x="457200" y="274320"/>
             <a:ext cx="8229600" cy="457200"/>
           </a:xfrm>
           <a:prstGeom prst="rect">
@@ -13506,7 +13506,7 @@
         </p:nvSpPr>
         <p:spPr>
           <a:xfrm>
-            <a:off x="457200" y="228600"/>
+            <a:off x="457200" y="274320"/>
             <a:ext cx="8229600" cy="457200"/>
           </a:xfrm>
           <a:prstGeom prst="rect">
@@ -13546,7 +13546,7 @@
         <p:spPr>
           <a:xfrm>
             <a:off x="457200" y="914400"/>
-            <a:ext cx="8229600" cy="3657600"/>
+            <a:ext cx="8229600" cy="3474720"/>
           </a:xfrm>
           <a:prstGeom prst="rect">
             <a:avLst/>
@@ -13766,8 +13766,8 @@
         </p:nvSpPr>
         <p:spPr>
           <a:xfrm>
-            <a:off x="731520" y="1371600"/>
-            <a:ext cx="7680960" cy="548640"/>
+            <a:off x="731520" y="1645920"/>
+            <a:ext cx="7680960" cy="457200"/>
           </a:xfrm>
           <a:prstGeom prst="rect">
             <a:avLst/>
@@ -13805,7 +13805,7 @@
         </p:nvSpPr>
         <p:spPr>
           <a:xfrm>
-            <a:off x="731520" y="2011680"/>
+            <a:off x="731520" y="2194560"/>
             <a:ext cx="7680960" cy="731520"/>
           </a:xfrm>
           <a:prstGeom prst="rect">
@@ -13822,7 +13822,7 @@
               <a:buNone/>
             </a:pPr>
             <a:r>
-              <a:rPr lang="en-US" sz="3000" b="1" dirty="0">
+              <a:rPr lang="en-US" sz="2800" b="1" dirty="0">
                 <a:solidFill>
                   <a:srgbClr val="FFFFFF"/>
                 </a:solidFill>
@@ -13832,7 +13832,7 @@
               </a:rPr>
               <a:t>稻盛經營哲學</a:t>
             </a:r>
-            <a:endParaRPr lang="en-US" sz="3000" dirty="0"/>
+            <a:endParaRPr lang="en-US" sz="2800" dirty="0"/>
           </a:p>
         </p:txBody>
       </p:sp>
@@ -13844,7 +13844,7 @@
         </p:nvSpPr>
         <p:spPr>
           <a:xfrm>
-            <a:off x="731520" y="2926080"/>
+            <a:off x="731520" y="3017520"/>
             <a:ext cx="7680960" cy="548640"/>
           </a:xfrm>
           <a:prstGeom prst="rect">
@@ -13974,7 +13974,7 @@
         </p:nvSpPr>
         <p:spPr>
           <a:xfrm>
-            <a:off x="457200" y="228600"/>
+            <a:off x="457200" y="274320"/>
             <a:ext cx="8229600" cy="457200"/>
           </a:xfrm>
           <a:prstGeom prst="rect">
@@ -14014,7 +14014,7 @@
         <p:spPr>
           <a:xfrm>
             <a:off x="457200" y="914400"/>
-            <a:ext cx="8229600" cy="3657600"/>
+            <a:ext cx="8229600" cy="3474720"/>
           </a:xfrm>
           <a:prstGeom prst="rect">
             <a:avLst/>
@@ -14234,7 +14234,7 @@
         </p:nvSpPr>
         <p:spPr>
           <a:xfrm>
-            <a:off x="457200" y="228600"/>
+            <a:off x="457200" y="274320"/>
             <a:ext cx="8229600" cy="457200"/>
           </a:xfrm>
           <a:prstGeom prst="rect">
@@ -14274,7 +14274,7 @@
         <p:spPr>
           <a:xfrm>
             <a:off x="457200" y="914400"/>
-            <a:ext cx="8229600" cy="3657600"/>
+            <a:ext cx="8229600" cy="3474720"/>
           </a:xfrm>
           <a:prstGeom prst="rect">
             <a:avLst/>
@@ -14494,7 +14494,7 @@
         </p:nvSpPr>
         <p:spPr>
           <a:xfrm>
-            <a:off x="457200" y="228600"/>
+            <a:off x="457200" y="274320"/>
             <a:ext cx="8229600" cy="457200"/>
           </a:xfrm>
           <a:prstGeom prst="rect">
@@ -14534,7 +14534,7 @@
         <p:spPr>
           <a:xfrm>
             <a:off x="457200" y="914400"/>
-            <a:ext cx="8229600" cy="3657600"/>
+            <a:ext cx="8229600" cy="3474720"/>
           </a:xfrm>
           <a:prstGeom prst="rect">
             <a:avLst/>
@@ -14761,8 +14761,8 @@
         </p:nvSpPr>
         <p:spPr>
           <a:xfrm>
-            <a:off x="731520" y="1371600"/>
-            <a:ext cx="7680960" cy="548640"/>
+            <a:off x="731520" y="1645920"/>
+            <a:ext cx="7680960" cy="457200"/>
           </a:xfrm>
           <a:prstGeom prst="rect">
             <a:avLst/>
@@ -14800,7 +14800,7 @@
         </p:nvSpPr>
         <p:spPr>
           <a:xfrm>
-            <a:off x="731520" y="2011680"/>
+            <a:off x="731520" y="2194560"/>
             <a:ext cx="7680960" cy="731520"/>
           </a:xfrm>
           <a:prstGeom prst="rect">
@@ -14817,7 +14817,7 @@
               <a:buNone/>
             </a:pPr>
             <a:r>
-              <a:rPr lang="en-US" sz="3000" b="1" dirty="0">
+              <a:rPr lang="en-US" sz="2800" b="1" dirty="0">
                 <a:solidFill>
                   <a:srgbClr val="FFFFFF"/>
                 </a:solidFill>
@@ -14827,7 +14827,7 @@
               </a:rPr>
               <a:t>三大成功案例</a:t>
             </a:r>
-            <a:endParaRPr lang="en-US" sz="3000" dirty="0"/>
+            <a:endParaRPr lang="en-US" sz="2800" dirty="0"/>
           </a:p>
         </p:txBody>
       </p:sp>
@@ -14839,7 +14839,7 @@
         </p:nvSpPr>
         <p:spPr>
           <a:xfrm>
-            <a:off x="731520" y="2926080"/>
+            <a:off x="731520" y="3017520"/>
             <a:ext cx="7680960" cy="548640"/>
           </a:xfrm>
           <a:prstGeom prst="rect">
@@ -14969,7 +14969,7 @@
         </p:nvSpPr>
         <p:spPr>
           <a:xfrm>
-            <a:off x="457200" y="228600"/>
+            <a:off x="457200" y="274320"/>
             <a:ext cx="8229600" cy="457200"/>
           </a:xfrm>
           <a:prstGeom prst="rect">
@@ -16227,8 +16227,8 @@
         </p:nvSpPr>
         <p:spPr>
           <a:xfrm>
-            <a:off x="731520" y="1371600"/>
-            <a:ext cx="7680960" cy="548640"/>
+            <a:off x="731520" y="1645920"/>
+            <a:ext cx="7680960" cy="457200"/>
           </a:xfrm>
           <a:prstGeom prst="rect">
             <a:avLst/>
@@ -16266,7 +16266,7 @@
         </p:nvSpPr>
         <p:spPr>
           <a:xfrm>
-            <a:off x="731520" y="2011680"/>
+            <a:off x="731520" y="2194560"/>
             <a:ext cx="7680960" cy="731520"/>
           </a:xfrm>
           <a:prstGeom prst="rect">
@@ -16283,7 +16283,7 @@
               <a:buNone/>
             </a:pPr>
             <a:r>
-              <a:rPr lang="en-US" sz="3000" b="1" dirty="0">
+              <a:rPr lang="en-US" sz="2800" b="1" dirty="0">
                 <a:solidFill>
                   <a:srgbClr val="FFFFFF"/>
                 </a:solidFill>
@@ -16293,7 +16293,7 @@
               </a:rPr>
               <a:t>稻盛和夫與企業傳奇</a:t>
             </a:r>
-            <a:endParaRPr lang="en-US" sz="3000" dirty="0"/>
+            <a:endParaRPr lang="en-US" sz="2800" dirty="0"/>
           </a:p>
         </p:txBody>
       </p:sp>
@@ -16305,7 +16305,7 @@
         </p:nvSpPr>
         <p:spPr>
           <a:xfrm>
-            <a:off x="731520" y="2926080"/>
+            <a:off x="731520" y="3017520"/>
             <a:ext cx="7680960" cy="548640"/>
           </a:xfrm>
           <a:prstGeom prst="rect">
@@ -16435,7 +16435,7 @@
         </p:nvSpPr>
         <p:spPr>
           <a:xfrm>
-            <a:off x="457200" y="228600"/>
+            <a:off x="457200" y="274320"/>
             <a:ext cx="8229600" cy="457200"/>
           </a:xfrm>
           <a:prstGeom prst="rect">
@@ -16475,7 +16475,7 @@
         <p:spPr>
           <a:xfrm>
             <a:off x="457200" y="914400"/>
-            <a:ext cx="8229600" cy="3657600"/>
+            <a:ext cx="8229600" cy="3474720"/>
           </a:xfrm>
           <a:prstGeom prst="rect">
             <a:avLst/>
@@ -16677,8 +16677,8 @@
         </p:nvSpPr>
         <p:spPr>
           <a:xfrm>
-            <a:off x="731520" y="1371600"/>
-            <a:ext cx="7680960" cy="548640"/>
+            <a:off x="731520" y="1645920"/>
+            <a:ext cx="7680960" cy="457200"/>
           </a:xfrm>
           <a:prstGeom prst="rect">
             <a:avLst/>
@@ -16716,7 +16716,7 @@
         </p:nvSpPr>
         <p:spPr>
           <a:xfrm>
-            <a:off x="731520" y="2011680"/>
+            <a:off x="731520" y="2194560"/>
             <a:ext cx="7680960" cy="731520"/>
           </a:xfrm>
           <a:prstGeom prst="rect">
@@ -16733,7 +16733,7 @@
               <a:buNone/>
             </a:pPr>
             <a:r>
-              <a:rPr lang="en-US" sz="3000" b="1" dirty="0">
+              <a:rPr lang="en-US" sz="2800" b="1" dirty="0">
                 <a:solidFill>
                   <a:srgbClr val="FFFFFF"/>
                 </a:solidFill>
@@ -16743,7 +16743,7 @@
               </a:rPr>
               <a:t>常見錯誤與成功關鍵</a:t>
             </a:r>
-            <a:endParaRPr lang="en-US" sz="3000" dirty="0"/>
+            <a:endParaRPr lang="en-US" sz="2800" dirty="0"/>
           </a:p>
         </p:txBody>
       </p:sp>
@@ -16755,7 +16755,7 @@
         </p:nvSpPr>
         <p:spPr>
           <a:xfrm>
-            <a:off x="731520" y="2926080"/>
+            <a:off x="731520" y="3017520"/>
             <a:ext cx="7680960" cy="548640"/>
           </a:xfrm>
           <a:prstGeom prst="rect">
@@ -16885,7 +16885,7 @@
         </p:nvSpPr>
         <p:spPr>
           <a:xfrm>
-            <a:off x="457200" y="228600"/>
+            <a:off x="457200" y="274320"/>
             <a:ext cx="8229600" cy="457200"/>
           </a:xfrm>
           <a:prstGeom prst="rect">
@@ -18115,7 +18115,7 @@
         </p:nvSpPr>
         <p:spPr>
           <a:xfrm>
-            <a:off x="457200" y="228600"/>
+            <a:off x="457200" y="274320"/>
             <a:ext cx="8229600" cy="457200"/>
           </a:xfrm>
           <a:prstGeom prst="rect">
@@ -18155,7 +18155,7 @@
         <p:spPr>
           <a:xfrm>
             <a:off x="457200" y="914400"/>
-            <a:ext cx="8229600" cy="3657600"/>
+            <a:ext cx="8229600" cy="3474720"/>
           </a:xfrm>
           <a:prstGeom prst="rect">
             <a:avLst/>
@@ -18357,8 +18357,8 @@
         </p:nvSpPr>
         <p:spPr>
           <a:xfrm>
-            <a:off x="731520" y="1371600"/>
-            <a:ext cx="7680960" cy="548640"/>
+            <a:off x="731520" y="1645920"/>
+            <a:ext cx="7680960" cy="457200"/>
           </a:xfrm>
           <a:prstGeom prst="rect">
             <a:avLst/>
@@ -18396,7 +18396,7 @@
         </p:nvSpPr>
         <p:spPr>
           <a:xfrm>
-            <a:off x="731520" y="2011680"/>
+            <a:off x="731520" y="2194560"/>
             <a:ext cx="7680960" cy="731520"/>
           </a:xfrm>
           <a:prstGeom prst="rect">
@@ -18413,7 +18413,7 @@
               <a:buNone/>
             </a:pPr>
             <a:r>
-              <a:rPr lang="en-US" sz="3000" b="1" dirty="0">
+              <a:rPr lang="en-US" sz="2800" b="1" dirty="0">
                 <a:solidFill>
                   <a:srgbClr val="FFFFFF"/>
                 </a:solidFill>
@@ -18423,7 +18423,7 @@
               </a:rPr>
               <a:t>導入步驟與實作清單</a:t>
             </a:r>
-            <a:endParaRPr lang="en-US" sz="3000" dirty="0"/>
+            <a:endParaRPr lang="en-US" sz="2800" dirty="0"/>
           </a:p>
         </p:txBody>
       </p:sp>
@@ -18435,7 +18435,7 @@
         </p:nvSpPr>
         <p:spPr>
           <a:xfrm>
-            <a:off x="731520" y="2926080"/>
+            <a:off x="731520" y="3017520"/>
             <a:ext cx="7680960" cy="548640"/>
           </a:xfrm>
           <a:prstGeom prst="rect">
@@ -18565,7 +18565,7 @@
         </p:nvSpPr>
         <p:spPr>
           <a:xfrm>
-            <a:off x="457200" y="228600"/>
+            <a:off x="457200" y="274320"/>
             <a:ext cx="8229600" cy="457200"/>
           </a:xfrm>
           <a:prstGeom prst="rect">
@@ -18605,7 +18605,7 @@
         <p:spPr>
           <a:xfrm>
             <a:off x="457200" y="914400"/>
-            <a:ext cx="8229600" cy="3657600"/>
+            <a:ext cx="8229600" cy="3474720"/>
           </a:xfrm>
           <a:prstGeom prst="rect">
             <a:avLst/>
@@ -18770,12 +18770,12 @@
         </p:nvSpPr>
         <p:spPr>
           <a:xfrm>
-            <a:off x="457200" y="3931920"/>
-            <a:ext cx="8229600" cy="640080"/>
+            <a:off x="457200" y="3840480"/>
+            <a:ext cx="8229600" cy="731520"/>
           </a:xfrm>
           <a:prstGeom prst="roundRect">
             <a:avLst>
-              <a:gd name="adj" fmla="val 571429"/>
+              <a:gd name="adj" fmla="val 500000"/>
             </a:avLst>
           </a:prstGeom>
           <a:solidFill>
@@ -18792,8 +18792,8 @@
         </p:nvSpPr>
         <p:spPr>
           <a:xfrm>
-            <a:off x="640080" y="3977640"/>
-            <a:ext cx="7863840" cy="548640"/>
+            <a:off x="640080" y="3886200"/>
+            <a:ext cx="7863840" cy="640080"/>
           </a:xfrm>
           <a:prstGeom prst="rect">
             <a:avLst/>
@@ -18922,7 +18922,7 @@
         </p:nvSpPr>
         <p:spPr>
           <a:xfrm>
-            <a:off x="457200" y="228600"/>
+            <a:off x="457200" y="274320"/>
             <a:ext cx="8229600" cy="457200"/>
           </a:xfrm>
           <a:prstGeom prst="rect">
@@ -20493,8 +20493,8 @@
         </p:nvSpPr>
         <p:spPr>
           <a:xfrm>
-            <a:off x="731520" y="1371600"/>
-            <a:ext cx="7680960" cy="548640"/>
+            <a:off x="731520" y="1645920"/>
+            <a:ext cx="7680960" cy="457200"/>
           </a:xfrm>
           <a:prstGeom prst="rect">
             <a:avLst/>
@@ -20532,7 +20532,7 @@
         </p:nvSpPr>
         <p:spPr>
           <a:xfrm>
-            <a:off x="731520" y="2011680"/>
+            <a:off x="731520" y="2194560"/>
             <a:ext cx="7680960" cy="731520"/>
           </a:xfrm>
           <a:prstGeom prst="rect">
@@ -20549,7 +20549,7 @@
               <a:buNone/>
             </a:pPr>
             <a:r>
-              <a:rPr lang="en-US" sz="3000" b="1" dirty="0">
+              <a:rPr lang="en-US" sz="2800" b="1" dirty="0">
                 <a:solidFill>
                   <a:srgbClr val="FFFFFF"/>
                 </a:solidFill>
@@ -20559,7 +20559,7 @@
               </a:rPr>
               <a:t>資源與延伸閱讀</a:t>
             </a:r>
-            <a:endParaRPr lang="en-US" sz="3000" dirty="0"/>
+            <a:endParaRPr lang="en-US" sz="2800" dirty="0"/>
           </a:p>
         </p:txBody>
       </p:sp>
@@ -20571,7 +20571,7 @@
         </p:nvSpPr>
         <p:spPr>
           <a:xfrm>
-            <a:off x="731520" y="2926080"/>
+            <a:off x="731520" y="3017520"/>
             <a:ext cx="7680960" cy="548640"/>
           </a:xfrm>
           <a:prstGeom prst="rect">
@@ -20701,7 +20701,7 @@
         </p:nvSpPr>
         <p:spPr>
           <a:xfrm>
-            <a:off x="457200" y="228600"/>
+            <a:off x="457200" y="274320"/>
             <a:ext cx="8229600" cy="457200"/>
           </a:xfrm>
           <a:prstGeom prst="rect">
@@ -20741,7 +20741,7 @@
         <p:spPr>
           <a:xfrm>
             <a:off x="457200" y="914400"/>
-            <a:ext cx="8229600" cy="3657600"/>
+            <a:ext cx="8229600" cy="3474720"/>
           </a:xfrm>
           <a:prstGeom prst="rect">
             <a:avLst/>
@@ -20961,8 +20961,8 @@
         </p:nvSpPr>
         <p:spPr>
           <a:xfrm>
-            <a:off x="731520" y="1371600"/>
-            <a:ext cx="7680960" cy="548640"/>
+            <a:off x="731520" y="1645920"/>
+            <a:ext cx="7680960" cy="457200"/>
           </a:xfrm>
           <a:prstGeom prst="rect">
             <a:avLst/>
@@ -21000,7 +21000,7 @@
         </p:nvSpPr>
         <p:spPr>
           <a:xfrm>
-            <a:off x="731520" y="2011680"/>
+            <a:off x="731520" y="2194560"/>
             <a:ext cx="7680960" cy="731520"/>
           </a:xfrm>
           <a:prstGeom prst="rect">
@@ -21017,7 +21017,7 @@
               <a:buNone/>
             </a:pPr>
             <a:r>
-              <a:rPr lang="en-US" sz="3000" b="1" dirty="0">
+              <a:rPr lang="en-US" sz="2800" b="1" dirty="0">
                 <a:solidFill>
                   <a:srgbClr val="FFFFFF"/>
                 </a:solidFill>
@@ -21027,7 +21027,7 @@
               </a:rPr>
               <a:t>總結與 Q&amp;A</a:t>
             </a:r>
-            <a:endParaRPr lang="en-US" sz="3000" dirty="0"/>
+            <a:endParaRPr lang="en-US" sz="2800" dirty="0"/>
           </a:p>
         </p:txBody>
       </p:sp>
@@ -21130,7 +21130,7 @@
         </p:nvSpPr>
         <p:spPr>
           <a:xfrm>
-            <a:off x="457200" y="228600"/>
+            <a:off x="457200" y="274320"/>
             <a:ext cx="8229600" cy="457200"/>
           </a:xfrm>
           <a:prstGeom prst="rect">
@@ -21170,7 +21170,7 @@
         <p:spPr>
           <a:xfrm>
             <a:off x="457200" y="914400"/>
-            <a:ext cx="8229600" cy="3657600"/>
+            <a:ext cx="8229600" cy="3474720"/>
           </a:xfrm>
           <a:prstGeom prst="rect">
             <a:avLst/>
@@ -21299,12 +21299,12 @@
         </p:nvSpPr>
         <p:spPr>
           <a:xfrm>
-            <a:off x="457200" y="3931920"/>
-            <a:ext cx="8229600" cy="640080"/>
+            <a:off x="457200" y="3840480"/>
+            <a:ext cx="8229600" cy="731520"/>
           </a:xfrm>
           <a:prstGeom prst="roundRect">
             <a:avLst>
-              <a:gd name="adj" fmla="val 571429"/>
+              <a:gd name="adj" fmla="val 500000"/>
             </a:avLst>
           </a:prstGeom>
           <a:solidFill>
@@ -21321,8 +21321,8 @@
         </p:nvSpPr>
         <p:spPr>
           <a:xfrm>
-            <a:off x="640080" y="3977640"/>
-            <a:ext cx="7863840" cy="548640"/>
+            <a:off x="640080" y="3886200"/>
+            <a:ext cx="7863840" cy="640080"/>
           </a:xfrm>
           <a:prstGeom prst="rect">
             <a:avLst/>
@@ -21451,7 +21451,7 @@
         </p:nvSpPr>
         <p:spPr>
           <a:xfrm>
-            <a:off x="457200" y="228600"/>
+            <a:off x="457200" y="274320"/>
             <a:ext cx="8229600" cy="457200"/>
           </a:xfrm>
           <a:prstGeom prst="rect">
@@ -21491,7 +21491,7 @@
         <p:spPr>
           <a:xfrm>
             <a:off x="457200" y="914400"/>
-            <a:ext cx="8229600" cy="3657600"/>
+            <a:ext cx="8229600" cy="3474720"/>
           </a:xfrm>
           <a:prstGeom prst="rect">
             <a:avLst/>
@@ -21620,12 +21620,12 @@
         </p:nvSpPr>
         <p:spPr>
           <a:xfrm>
-            <a:off x="457200" y="3931920"/>
-            <a:ext cx="8229600" cy="640080"/>
+            <a:off x="457200" y="3840480"/>
+            <a:ext cx="8229600" cy="731520"/>
           </a:xfrm>
           <a:prstGeom prst="roundRect">
             <a:avLst>
-              <a:gd name="adj" fmla="val 571429"/>
+              <a:gd name="adj" fmla="val 500000"/>
             </a:avLst>
           </a:prstGeom>
           <a:solidFill>
@@ -21642,8 +21642,8 @@
         </p:nvSpPr>
         <p:spPr>
           <a:xfrm>
-            <a:off x="640080" y="3977640"/>
-            <a:ext cx="7863840" cy="548640"/>
+            <a:off x="640080" y="3886200"/>
+            <a:ext cx="7863840" cy="640080"/>
           </a:xfrm>
           <a:prstGeom prst="rect">
             <a:avLst/>
@@ -21772,7 +21772,7 @@
         </p:nvSpPr>
         <p:spPr>
           <a:xfrm>
-            <a:off x="457200" y="228600"/>
+            <a:off x="457200" y="274320"/>
             <a:ext cx="8229600" cy="457200"/>
           </a:xfrm>
           <a:prstGeom prst="rect">
@@ -21812,7 +21812,7 @@
         <p:spPr>
           <a:xfrm>
             <a:off x="457200" y="914400"/>
-            <a:ext cx="8229600" cy="3657600"/>
+            <a:ext cx="8229600" cy="3474720"/>
           </a:xfrm>
           <a:prstGeom prst="rect">
             <a:avLst/>
@@ -21923,12 +21923,12 @@
         </p:nvSpPr>
         <p:spPr>
           <a:xfrm>
-            <a:off x="457200" y="3931920"/>
-            <a:ext cx="8229600" cy="640080"/>
+            <a:off x="457200" y="3840480"/>
+            <a:ext cx="8229600" cy="731520"/>
           </a:xfrm>
           <a:prstGeom prst="roundRect">
             <a:avLst>
-              <a:gd name="adj" fmla="val 571429"/>
+              <a:gd name="adj" fmla="val 500000"/>
             </a:avLst>
           </a:prstGeom>
           <a:solidFill>
@@ -21945,8 +21945,8 @@
         </p:nvSpPr>
         <p:spPr>
           <a:xfrm>
-            <a:off x="640080" y="3977640"/>
-            <a:ext cx="7863840" cy="548640"/>
+            <a:off x="640080" y="3886200"/>
+            <a:ext cx="7863840" cy="640080"/>
           </a:xfrm>
           <a:prstGeom prst="rect">
             <a:avLst/>
@@ -22075,7 +22075,7 @@
         </p:nvSpPr>
         <p:spPr>
           <a:xfrm>
-            <a:off x="457200" y="228600"/>
+            <a:off x="457200" y="274320"/>
             <a:ext cx="8229600" cy="457200"/>
           </a:xfrm>
           <a:prstGeom prst="rect">
@@ -22115,7 +22115,7 @@
         <p:spPr>
           <a:xfrm>
             <a:off x="457200" y="914400"/>
-            <a:ext cx="8229600" cy="3657600"/>
+            <a:ext cx="8229600" cy="3474720"/>
           </a:xfrm>
           <a:prstGeom prst="rect">
             <a:avLst/>
@@ -22244,12 +22244,12 @@
         </p:nvSpPr>
         <p:spPr>
           <a:xfrm>
-            <a:off x="457200" y="3931920"/>
-            <a:ext cx="8229600" cy="640080"/>
+            <a:off x="457200" y="3840480"/>
+            <a:ext cx="8229600" cy="731520"/>
           </a:xfrm>
           <a:prstGeom prst="roundRect">
             <a:avLst>
-              <a:gd name="adj" fmla="val 571429"/>
+              <a:gd name="adj" fmla="val 500000"/>
             </a:avLst>
           </a:prstGeom>
           <a:solidFill>
@@ -22266,8 +22266,8 @@
         </p:nvSpPr>
         <p:spPr>
           <a:xfrm>
-            <a:off x="640080" y="3977640"/>
-            <a:ext cx="7863840" cy="548640"/>
+            <a:off x="640080" y="3886200"/>
+            <a:ext cx="7863840" cy="640080"/>
           </a:xfrm>
           <a:prstGeom prst="rect">
             <a:avLst/>
@@ -22396,8 +22396,8 @@
         </p:nvSpPr>
         <p:spPr>
           <a:xfrm>
-            <a:off x="731520" y="1371600"/>
-            <a:ext cx="7680960" cy="548640"/>
+            <a:off x="731520" y="1645920"/>
+            <a:ext cx="7680960" cy="457200"/>
           </a:xfrm>
           <a:prstGeom prst="rect">
             <a:avLst/>
@@ -22435,7 +22435,7 @@
         </p:nvSpPr>
         <p:spPr>
           <a:xfrm>
-            <a:off x="731520" y="2011680"/>
+            <a:off x="731520" y="2194560"/>
             <a:ext cx="7680960" cy="731520"/>
           </a:xfrm>
           <a:prstGeom prst="rect">
@@ -22452,7 +22452,7 @@
               <a:buNone/>
             </a:pPr>
             <a:r>
-              <a:rPr lang="en-US" sz="3000" b="1" dirty="0">
+              <a:rPr lang="en-US" sz="2800" b="1" dirty="0">
                 <a:solidFill>
                   <a:srgbClr val="FFFFFF"/>
                 </a:solidFill>
@@ -22462,7 +22462,7 @@
               </a:rPr>
               <a:t>阿米巴核心理論</a:t>
             </a:r>
-            <a:endParaRPr lang="en-US" sz="3000" dirty="0"/>
+            <a:endParaRPr lang="en-US" sz="2800" dirty="0"/>
           </a:p>
         </p:txBody>
       </p:sp>
@@ -22474,7 +22474,7 @@
         </p:nvSpPr>
         <p:spPr>
           <a:xfrm>
-            <a:off x="731520" y="2926080"/>
+            <a:off x="731520" y="3017520"/>
             <a:ext cx="7680960" cy="548640"/>
           </a:xfrm>
           <a:prstGeom prst="rect">
@@ -22604,7 +22604,7 @@
         </p:nvSpPr>
         <p:spPr>
           <a:xfrm>
-            <a:off x="457200" y="228600"/>
+            <a:off x="457200" y="274320"/>
             <a:ext cx="8229600" cy="457200"/>
           </a:xfrm>
           <a:prstGeom prst="rect">
@@ -22644,7 +22644,7 @@
         <p:spPr>
           <a:xfrm>
             <a:off x="457200" y="914400"/>
-            <a:ext cx="8229600" cy="3657600"/>
+            <a:ext cx="8229600" cy="3474720"/>
           </a:xfrm>
           <a:prstGeom prst="rect">
             <a:avLst/>
@@ -22755,12 +22755,12 @@
         </p:nvSpPr>
         <p:spPr>
           <a:xfrm>
-            <a:off x="457200" y="3931920"/>
-            <a:ext cx="8229600" cy="640080"/>
+            <a:off x="457200" y="3840480"/>
+            <a:ext cx="8229600" cy="731520"/>
           </a:xfrm>
           <a:prstGeom prst="roundRect">
             <a:avLst>
-              <a:gd name="adj" fmla="val 571429"/>
+              <a:gd name="adj" fmla="val 500000"/>
             </a:avLst>
           </a:prstGeom>
           <a:solidFill>
@@ -22777,8 +22777,8 @@
         </p:nvSpPr>
         <p:spPr>
           <a:xfrm>
-            <a:off x="640080" y="3977640"/>
-            <a:ext cx="7863840" cy="548640"/>
+            <a:off x="640080" y="3886200"/>
+            <a:ext cx="7863840" cy="640080"/>
           </a:xfrm>
           <a:prstGeom prst="rect">
             <a:avLst/>
@@ -22907,7 +22907,7 @@
         </p:nvSpPr>
         <p:spPr>
           <a:xfrm>
-            <a:off x="457200" y="228600"/>
+            <a:off x="457200" y="274320"/>
             <a:ext cx="8229600" cy="457200"/>
           </a:xfrm>
           <a:prstGeom prst="rect">
@@ -22947,7 +22947,7 @@
         <p:spPr>
           <a:xfrm>
             <a:off x="457200" y="914400"/>
-            <a:ext cx="8229600" cy="3657600"/>
+            <a:ext cx="8229600" cy="3474720"/>
           </a:xfrm>
           <a:prstGeom prst="rect">
             <a:avLst/>

</xml_diff>